<commit_message>
Redraw AI Hub after published Techtouch AI Hub screens
- AI step triggered by a button Techtouch places on the screen
- Waiting state fades the page with blue 'please wait' text
- Results shown as an 'AIチェック' balloon (yellow header bar, internal
  rule table) or a result popup (illustration, section header, copy
  button), each with the 'AI may be inaccurate' note and a concept tag
- Decks: recaptured images and updated legend text

Co-Authored-By: Claude Opus 5.5 <noreply@anthropic.com>
Claude-Session: https://claude.ai/code/session_01XzPVxy2UuwyH8y5dYU3JCd
</commit_message>
<xml_diff>
--- a/splunk-techtouch-demo/slides/Splunk障害対応・ログ分析デモ_事前説明.pptx
+++ b/splunk-techtouch-demo/slides/Splunk障害対応・ログ分析デモ_事前説明.pptx
@@ -121,13 +121,13 @@
   <p:extLst>
     <p:ext uri="{521415D9-36F7-43E2-AB2F-B90AF26B5E84}">
       <p14:sectionLst xmlns:p14="http://schemas.microsoft.com/office/powerpoint/2010/main">
-        <p14:section name="はじめに" id="{c5dd5e9c-b99c-b787-ce9d-58b5ae355d51}">
+        <p14:section name="はじめに" id="{1d4883df-e606-6922-3c87-5a73be3808fe}">
           <p14:sldIdLst>
             <p14:sldId id="256"/>
             <p14:sldId id="257"/>
           </p14:sldIdLst>
         </p14:section>
-        <p14:section name="シナリオ" id="{95ad7e66-7017-77af-fcac-a0a37a90676e}">
+        <p14:section name="シナリオ" id="{38cf9f69-6a3c-3460-310e-dee29c6bbbf6}">
           <p14:sldIdLst>
             <p14:sldId id="258"/>
             <p14:sldId id="259"/>
@@ -136,7 +136,7 @@
             <p14:sldId id="262"/>
           </p14:sldIdLst>
         </p14:section>
-        <p14:section name="デモ" id="{7c623a4b-da07-ab39-0a3d-4a0837abf792}">
+        <p14:section name="デモ" id="{826348cb-bc54-8a37-25c0-dfbde3e510fa}">
           <p14:sldIdLst>
             <p14:sldId id="263"/>
             <p14:sldId id="264"/>
@@ -144,7 +144,7 @@
             <p14:sldId id="266"/>
           </p14:sldIdLst>
         </p14:section>
-        <p14:section name="進め方" id="{448bf753-eb6e-2a62-0c9a-25f04dc8aa51}">
+        <p14:section name="進め方" id="{8569c2e5-f769-47d0-c421-1566982a07ca}">
           <p14:sldIdLst>
             <p14:sldId id="267"/>
             <p14:sldId id="268"/>
@@ -20310,7 +20310,7 @@
                   <a:schemeClr val="tx1"/>
                 </a:solidFill>
               </a:rPr>
-              <a:t>AI Hubが、社内手順の形で一次連絡文を下書きする</a:t>
+              <a:t>画面に置いたAIボタンから、AI Hubが一次連絡文の案を作る</a:t>
             </a:r>
             <a:endParaRPr lang="en-US" sz="1200" dirty="0"/>
           </a:p>
@@ -20540,7 +20540,7 @@
                   <a:schemeClr val="tx1"/>
                 </a:solidFill>
               </a:rPr>
-              <a:t>公開したガイドの吹き出し⑤と、AI Hubによる結果の読み方</a:t>
+              <a:t>公開したガイドの吹き出し⑤と、AIチェック（社内基準との照合）</a:t>
             </a:r>
             <a:endParaRPr lang="en-US" sz="1200" dirty="0"/>
           </a:p>
@@ -20623,7 +20623,7 @@
                   <a:schemeClr val="tx1"/>
                 </a:solidFill>
               </a:rPr>
-              <a:t>青い吹き出し・パネルがテックタッチのガイド、紫のパネルがAI Hub（構想・例文）です</a:t>
+              <a:t>青い吹き出し・パネルがテックタッチのガイド、紫の「AI Hub」の札が付いた吹き出しがAI Hub（構想・例文）です。AI Hubの見た目は、公開されている製品画面に合わせています</a:t>
             </a:r>
             <a:endParaRPr lang="en-US" sz="1200" dirty="0"/>
           </a:p>

</xml_diff>